<commit_message>
Esclarece coleta parcial nos slides e notas da entrega
</commit_message>
<xml_diff>
--- a/entregas/2026-10-27-entrega-04-java-final/Apresentacao-Entrega04-final.pptx
+++ b/entregas/2026-10-27-entrega-04-java-final/Apresentacao-Entrega04-final.pptx
@@ -2,22 +2,22 @@
 <file path=ppt/presentation.xml><?xml version="1.0" encoding="utf-8"?>
 <p:presentation xmlns:p="http://schemas.openxmlformats.org/presentationml/2006/main">
   <p:sldMasterIdLst>
-    <p:sldMasterId xmlns:r="http://schemas.openxmlformats.org/officeDocument/2006/relationships" id="2147483648" r:id="R3adb0f1cb0aa46e8"/>
+    <p:sldMasterId xmlns:r="http://schemas.openxmlformats.org/officeDocument/2006/relationships" id="2147483648" r:id="Ra4df260e64d543e9"/>
   </p:sldMasterIdLst>
   <p:notesMasterIdLst>
-    <p:notesMasterId xmlns:r="http://schemas.openxmlformats.org/officeDocument/2006/relationships" r:id="Rdf8242769c6640f7"/>
+    <p:notesMasterId xmlns:r="http://schemas.openxmlformats.org/officeDocument/2006/relationships" r:id="Rcd1ed113df55467e"/>
   </p:notesMasterIdLst>
   <p:sldIdLst>
-    <p:sldId xmlns:r="http://schemas.openxmlformats.org/officeDocument/2006/relationships" id="256" r:id="Re53bb82134f4457b"/>
-    <p:sldId xmlns:r="http://schemas.openxmlformats.org/officeDocument/2006/relationships" id="257" r:id="Rdada407abb8a458d"/>
-    <p:sldId xmlns:r="http://schemas.openxmlformats.org/officeDocument/2006/relationships" id="258" r:id="Rfc48a0b60f9740cd"/>
-    <p:sldId xmlns:r="http://schemas.openxmlformats.org/officeDocument/2006/relationships" id="259" r:id="R671e413128f34252"/>
-    <p:sldId xmlns:r="http://schemas.openxmlformats.org/officeDocument/2006/relationships" id="260" r:id="R05f9c720f48e425d"/>
-    <p:sldId xmlns:r="http://schemas.openxmlformats.org/officeDocument/2006/relationships" id="261" r:id="R449cb72ed74d4788"/>
-    <p:sldId xmlns:r="http://schemas.openxmlformats.org/officeDocument/2006/relationships" id="262" r:id="R346b20da807a42eb"/>
-    <p:sldId xmlns:r="http://schemas.openxmlformats.org/officeDocument/2006/relationships" id="263" r:id="Ref50f1e475b2412b"/>
-    <p:sldId xmlns:r="http://schemas.openxmlformats.org/officeDocument/2006/relationships" id="264" r:id="R26a3a84147a54619"/>
-    <p:sldId xmlns:r="http://schemas.openxmlformats.org/officeDocument/2006/relationships" id="265" r:id="R273352e90e444d37"/>
+    <p:sldId xmlns:r="http://schemas.openxmlformats.org/officeDocument/2006/relationships" id="256" r:id="R24b4524f51d84f8b"/>
+    <p:sldId xmlns:r="http://schemas.openxmlformats.org/officeDocument/2006/relationships" id="257" r:id="R485f6132bb7c4bf2"/>
+    <p:sldId xmlns:r="http://schemas.openxmlformats.org/officeDocument/2006/relationships" id="258" r:id="Rfc45581ee49b4d2a"/>
+    <p:sldId xmlns:r="http://schemas.openxmlformats.org/officeDocument/2006/relationships" id="259" r:id="R1aeee04699114386"/>
+    <p:sldId xmlns:r="http://schemas.openxmlformats.org/officeDocument/2006/relationships" id="260" r:id="Ra8e16b3782494f0c"/>
+    <p:sldId xmlns:r="http://schemas.openxmlformats.org/officeDocument/2006/relationships" id="261" r:id="R4db9577782064f49"/>
+    <p:sldId xmlns:r="http://schemas.openxmlformats.org/officeDocument/2006/relationships" id="262" r:id="Rf5ade5382b854e50"/>
+    <p:sldId xmlns:r="http://schemas.openxmlformats.org/officeDocument/2006/relationships" id="263" r:id="R79be93b558644c65"/>
+    <p:sldId xmlns:r="http://schemas.openxmlformats.org/officeDocument/2006/relationships" id="264" r:id="Rc10533a357c7400e"/>
+    <p:sldId xmlns:r="http://schemas.openxmlformats.org/officeDocument/2006/relationships" id="265" r:id="Rddfee70a1b3b441e"/>
   </p:sldIdLst>
   <p:sldSz cx="12192000" cy="6858000"/>
   <p:notesSz cx="6858000" cy="9144000"/>
@@ -451,7 +451,7 @@
           <a:lstStyle xmlns:a="http://schemas.openxmlformats.org/drawingml/2006/main"/>
           <a:p xmlns:a="http://schemas.openxmlformats.org/drawingml/2006/main">
             <a:r>
-              <a:t>Nesta apresentação eu mostro os resultados finais da comparação entre as duas implementações Java de registros de auditoria. A campanha terminou com todos os 65 identificadores planejados. O resultado científico tem uma ressalva importante: 64 coletas têm evidência completa e uma é parcial, porque falta o horário de um commit. Essa observação foi preservada e recebeu tratamento por métrica após revisão autorizada. O objetivo não é escolher uma tecnologia vencedora de antemão, mas mostrar os compromissos que apareceram nas condições medidas. Fonte: campanha R2/A1 de 27/10/2026, implementacao-java/experimento/campanhas/2026-10-27-reduzida65-r2/RESULTADOS.md e resultados-a1/. Documento consolidado no commit 771d7a621c31aaccda7359b8207979c4bc84f19d. </a:t>
+              <a:t>Nesta apresentação eu mostro os resultados finais da comparação entre as duas implementações Java de registros de auditoria. A campanha terminou com as 65 tentativas planejadas. Houve 64 coletas com evidência completa e uma com evidência temporal incompleta: um evento apareceu no banco apesar de HTTP 503, mas faltou o registro do horário de conclusão de seu commit. A comparação afetada utiliza quatro pares completos. No slide oito explico essa limitação e o tratamento adotado. O objetivo é mostrar os compromissos que apareceram nas condições medidas. Fonte: campanha R2/A1 de 27/10/2026, implementacao-java/experimento/campanhas/2026-10-27-reduzida65-r2/RESULTADOS.md e resultados-a1/. Documento consolidado no commit 771d7a621c31aaccda7359b8207979c4bc84f19d. </a:t>
             </a:r>
           </a:p>
         </p:txBody>
@@ -871,7 +871,7 @@
           <a:lstStyle xmlns:a="http://schemas.openxmlformats.org/drawingml/2006/main"/>
           <a:p xmlns:a="http://schemas.openxmlformats.org/drawingml/2006/main">
             <a:r>
-              <a:t>Durante as interrupções do banco, a síncrona retornou 2.452 erros 503. Seus 8.351 aceites foram persistidos, mas houve uma requisição adicional com erro que também deixou registro no banco. Isso gerou o caso de confirmação incerta que explico a seguir. A assíncrona aceitou os 10.804 envios com 202, porém somente 10.790 chegaram ao banco. Quatorze foram para a DLQ ao esgotar tentativas, em quantidades de três, três, três, três e dois por bloco. Elas ficaram com destino terminal conhecido, sem replay automático. DLQ significa não persistência no banco, não desaparecimento da mensagem. Não houve aceite sem destino conciliado ou UUID duplicado no banco. Fonte: campanha R2/A1 de 27/10/2026, implementacao-java/experimento/campanhas/2026-10-27-reduzida65-r2/RESULTADOS.md e resultados-a1/. Documento consolidado no commit 771d7a621c31aaccda7359b8207979c4bc84f19d. group-summary.json: postgres-stop, rate=12.</a:t>
+              <a:t>Durante as interrupções do banco, a síncrona retornou 2.452 erros 503. Seus 8.351 aceites foram persistidos, mas uma requisição adicional com erro também deixou registro no banco, sem o registro de seu horário de commit. A parada do banco fazia parte do teste. A falta dessa evidência temporal limitou uma coleta, cujo tratamento explico adiante. A assíncrona aceitou os 10.804 envios com 202, porém somente 10.790 chegaram ao banco. Quatorze foram para a DLQ ao esgotar tentativas, em quantidades de três, três, três, três e dois por bloco. Elas ficaram com destino terminal conhecido, sem replay automático. DLQ significa não persistência no banco, não desaparecimento da mensagem. Não houve aceite sem destino conciliado ou UUID duplicado no banco. Fonte: campanha R2/A1 de 27/10/2026, implementacao-java/experimento/campanhas/2026-10-27-reduzida65-r2/RESULTADOS.md e resultados-a1/. Documento consolidado no commit 771d7a621c31aaccda7359b8207979c4bc84f19d. group-summary.json: postgres-stop, rate=12.</a:t>
             </a:r>
           </a:p>
         </p:txBody>
@@ -1011,7 +1011,7 @@
           <a:lstStyle xmlns:a="http://schemas.openxmlformats.org/drawingml/2006/main"/>
           <a:p xmlns:a="http://schemas.openxmlformats.org/drawingml/2006/main">
             <a:r>
-              <a:t>A campanha parou na tentativa 37. Um evento síncrono retornou 503 e apareceu corretamente no banco, mas faltava seu marco pós-commit. O resumo bruto continua inválido. Após revisão formal e autorização, adotamos a A1 por métrica. Conservamos HTTP, destinos e recursos auditados, sem inventar o horário do commit. Excluímos a coleta e sua contraparte do bloco três da comparação primária de latência de conclusão, restando quatro pares nessa condição. Para a vazão parcial, apresentamos limites de contagem, não intervalo de confiança. A revisão é pós-hoc nas primeiras 37 e anterior às 28 restantes. Não repetimos UUIDs nem substituímos resultados. O catálogo final registra 64 completas e uma parcial. Fonte: campanha R2/A1 de 27/10/2026, implementacao-java/experimento/campanhas/2026-10-27-reduzida65-r2/RESULTADOS.md e resultados-a1/. Documento consolidado no commit 771d7a621c31aaccda7359b8207979c4bc84f19d. emenda-a1/README.md e strict-sensitivity.json.</a:t>
+              <a:t>Na tentativa 37, o teste interrompeu o PostgreSQL de forma planejada. Um evento da variante síncrona retornou HTTP 503 e apareceu no banco com conteúdo e hash corretos. Porém, faltou o registro do horário de conclusão de seu commit. Entre 1.667 registros persistidos nessa coleta, há tempos observados para 1.666. A persistência é comprovada, mas os logs não permitem determinar o instante daquele commit nem a causa exata da confirmação ausente. A falta dessa evidência temporal foi uma limitação não planejada da medição. Preservamos o veredito original inválido e não repetimos nem substituímos a coleta. A revisão A1 ocorreu após as primeiras 37 tentativas, antes das 28 restantes. Mantivemos HTTP, destinos e recursos auditados. O 503 continua contado como erro HTTP. A comparação primária de latência de conclusão com banco parado exclui essa coleta e sua contraparte do bloco três, restando quatro pares completos. Não estimamos o horário ausente. Para a vazão da parcial, os limites são de 9,25556 a 9,26111 eventos por segundo, sem constituir intervalo de confiança. A análise estrita também exclui esse par dos demais indicadores como sensibilidade. A campanha terminou com 64 coletas completas e uma com evidência temporal incompleta. Fonte: campanha R2/A1 de 27/10/2026, implementacao-java/experimento/campanhas/2026-10-27-reduzida65-r2/RESULTADOS.md e resultados-a1/. Documento consolidado no commit 771d7a621c31aaccda7359b8207979c4bc84f19d. emenda-a1/README.md e strict-sensitivity.json.</a:t>
             </a:r>
           </a:p>
         </p:txBody>
@@ -1149,7 +1149,7 @@
   </p:cSld>
   <p:clrMap bg1="lt1" tx1="dk1" bg2="lt2" tx2="dk2" accent1="accent1" accent2="accent2" accent3="accent3" accent4="accent4" accent5="accent5" accent6="accent6" hlink="hlink" folHlink="folHlink"/>
   <p:sldLayoutIdLst>
-    <p:sldLayoutId xmlns:r="http://schemas.openxmlformats.org/officeDocument/2006/relationships" id="2147483649" r:id="R95cadf0d70c542a1"/>
+    <p:sldLayoutId xmlns:r="http://schemas.openxmlformats.org/officeDocument/2006/relationships" id="2147483649" r:id="R091e0e8042764736"/>
   </p:sldLayoutIdLst>
   <p:txStyles>
     <p:titleStyle>
@@ -2197,6 +2197,7 @@
               </a:defRPr>
             </a:defPPr>
             <a:lvl1pPr>
+              <a:buNone/>
               <a:defRPr sz="2175" b="0">
                 <a:solidFill>
                   <a:srgbClr val="172B4D"/>
@@ -2207,6 +2208,7 @@
               </a:defRPr>
             </a:lvl1pPr>
             <a:lvl2pPr>
+              <a:buNone/>
               <a:defRPr sz="2175" b="0">
                 <a:solidFill>
                   <a:srgbClr val="172B4D"/>
@@ -2217,6 +2219,7 @@
               </a:defRPr>
             </a:lvl2pPr>
             <a:lvl3pPr>
+              <a:buNone/>
               <a:defRPr sz="2175" b="0">
                 <a:solidFill>
                   <a:srgbClr val="172B4D"/>
@@ -2227,6 +2230,7 @@
               </a:defRPr>
             </a:lvl3pPr>
             <a:lvl4pPr>
+              <a:buNone/>
               <a:defRPr sz="2175" b="0">
                 <a:solidFill>
                   <a:srgbClr val="172B4D"/>
@@ -2237,6 +2241,7 @@
               </a:defRPr>
             </a:lvl4pPr>
             <a:lvl5pPr>
+              <a:buNone/>
               <a:defRPr sz="2175" b="0">
                 <a:solidFill>
                   <a:srgbClr val="172B4D"/>
@@ -2247,6 +2252,7 @@
               </a:defRPr>
             </a:lvl5pPr>
             <a:lvl6pPr>
+              <a:buNone/>
               <a:defRPr sz="2175" b="0">
                 <a:solidFill>
                   <a:srgbClr val="172B4D"/>
@@ -2257,6 +2263,7 @@
               </a:defRPr>
             </a:lvl6pPr>
             <a:lvl7pPr>
+              <a:buNone/>
               <a:defRPr sz="2175" b="0">
                 <a:solidFill>
                   <a:srgbClr val="172B4D"/>
@@ -2267,6 +2274,7 @@
               </a:defRPr>
             </a:lvl7pPr>
             <a:lvl8pPr>
+              <a:buNone/>
               <a:defRPr sz="2175" b="0">
                 <a:solidFill>
                   <a:srgbClr val="172B4D"/>
@@ -2277,6 +2285,7 @@
               </a:defRPr>
             </a:lvl8pPr>
             <a:lvl9pPr>
+              <a:buNone/>
               <a:defRPr sz="2175" b="0">
                 <a:solidFill>
                   <a:srgbClr val="172B4D"/>
@@ -2289,6 +2298,7 @@
           </a:lstStyle>
           <a:p xmlns:a="http://schemas.openxmlformats.org/drawingml/2006/main">
             <a:pPr>
+              <a:buNone/>
               <a:defRPr sz="2175" b="0">
                 <a:solidFill>
                   <a:srgbClr val="172B4D"/>
@@ -2355,6 +2365,7 @@
               </a:defRPr>
             </a:defPPr>
             <a:lvl1pPr>
+              <a:buNone/>
               <a:defRPr sz="2175" b="0">
                 <a:solidFill>
                   <a:srgbClr val="172B4D"/>
@@ -2365,6 +2376,7 @@
               </a:defRPr>
             </a:lvl1pPr>
             <a:lvl2pPr>
+              <a:buNone/>
               <a:defRPr sz="2175" b="0">
                 <a:solidFill>
                   <a:srgbClr val="172B4D"/>
@@ -2375,6 +2387,7 @@
               </a:defRPr>
             </a:lvl2pPr>
             <a:lvl3pPr>
+              <a:buNone/>
               <a:defRPr sz="2175" b="0">
                 <a:solidFill>
                   <a:srgbClr val="172B4D"/>
@@ -2385,6 +2398,7 @@
               </a:defRPr>
             </a:lvl3pPr>
             <a:lvl4pPr>
+              <a:buNone/>
               <a:defRPr sz="2175" b="0">
                 <a:solidFill>
                   <a:srgbClr val="172B4D"/>
@@ -2395,6 +2409,7 @@
               </a:defRPr>
             </a:lvl4pPr>
             <a:lvl5pPr>
+              <a:buNone/>
               <a:defRPr sz="2175" b="0">
                 <a:solidFill>
                   <a:srgbClr val="172B4D"/>
@@ -2405,6 +2420,7 @@
               </a:defRPr>
             </a:lvl5pPr>
             <a:lvl6pPr>
+              <a:buNone/>
               <a:defRPr sz="2175" b="0">
                 <a:solidFill>
                   <a:srgbClr val="172B4D"/>
@@ -2415,6 +2431,7 @@
               </a:defRPr>
             </a:lvl6pPr>
             <a:lvl7pPr>
+              <a:buNone/>
               <a:defRPr sz="2175" b="0">
                 <a:solidFill>
                   <a:srgbClr val="172B4D"/>
@@ -2425,6 +2442,7 @@
               </a:defRPr>
             </a:lvl7pPr>
             <a:lvl8pPr>
+              <a:buNone/>
               <a:defRPr sz="2175" b="0">
                 <a:solidFill>
                   <a:srgbClr val="172B4D"/>
@@ -2435,6 +2453,7 @@
               </a:defRPr>
             </a:lvl8pPr>
             <a:lvl9pPr>
+              <a:buNone/>
               <a:defRPr sz="2175" b="0">
                 <a:solidFill>
                   <a:srgbClr val="172B4D"/>
@@ -2447,6 +2466,7 @@
           </a:lstStyle>
           <a:p xmlns:a="http://schemas.openxmlformats.org/drawingml/2006/main">
             <a:pPr>
+              <a:buNone/>
               <a:defRPr sz="2175" b="0">
                 <a:solidFill>
                   <a:srgbClr val="172B4D"/>
@@ -2513,6 +2533,7 @@
               </a:defRPr>
             </a:defPPr>
             <a:lvl1pPr>
+              <a:buNone/>
               <a:defRPr sz="2175" b="0">
                 <a:solidFill>
                   <a:srgbClr val="172B4D"/>
@@ -2523,6 +2544,7 @@
               </a:defRPr>
             </a:lvl1pPr>
             <a:lvl2pPr>
+              <a:buNone/>
               <a:defRPr sz="2175" b="0">
                 <a:solidFill>
                   <a:srgbClr val="172B4D"/>
@@ -2533,6 +2555,7 @@
               </a:defRPr>
             </a:lvl2pPr>
             <a:lvl3pPr>
+              <a:buNone/>
               <a:defRPr sz="2175" b="0">
                 <a:solidFill>
                   <a:srgbClr val="172B4D"/>
@@ -2543,6 +2566,7 @@
               </a:defRPr>
             </a:lvl3pPr>
             <a:lvl4pPr>
+              <a:buNone/>
               <a:defRPr sz="2175" b="0">
                 <a:solidFill>
                   <a:srgbClr val="172B4D"/>
@@ -2553,6 +2577,7 @@
               </a:defRPr>
             </a:lvl4pPr>
             <a:lvl5pPr>
+              <a:buNone/>
               <a:defRPr sz="2175" b="0">
                 <a:solidFill>
                   <a:srgbClr val="172B4D"/>
@@ -2563,6 +2588,7 @@
               </a:defRPr>
             </a:lvl5pPr>
             <a:lvl6pPr>
+              <a:buNone/>
               <a:defRPr sz="2175" b="0">
                 <a:solidFill>
                   <a:srgbClr val="172B4D"/>
@@ -2573,6 +2599,7 @@
               </a:defRPr>
             </a:lvl6pPr>
             <a:lvl7pPr>
+              <a:buNone/>
               <a:defRPr sz="2175" b="0">
                 <a:solidFill>
                   <a:srgbClr val="172B4D"/>
@@ -2583,6 +2610,7 @@
               </a:defRPr>
             </a:lvl7pPr>
             <a:lvl8pPr>
+              <a:buNone/>
               <a:defRPr sz="2175" b="0">
                 <a:solidFill>
                   <a:srgbClr val="172B4D"/>
@@ -2593,6 +2621,7 @@
               </a:defRPr>
             </a:lvl8pPr>
             <a:lvl9pPr>
+              <a:buNone/>
               <a:defRPr sz="2175" b="0">
                 <a:solidFill>
                   <a:srgbClr val="172B4D"/>
@@ -2605,6 +2634,7 @@
           </a:lstStyle>
           <a:p xmlns:a="http://schemas.openxmlformats.org/drawingml/2006/main">
             <a:pPr>
+              <a:buNone/>
               <a:defRPr sz="2175" b="0">
                 <a:solidFill>
                   <a:srgbClr val="172B4D"/>
@@ -2671,6 +2701,7 @@
               </a:defRPr>
             </a:defPPr>
             <a:lvl1pPr>
+              <a:buNone/>
               <a:defRPr sz="2175" b="0">
                 <a:solidFill>
                   <a:srgbClr val="172B4D"/>
@@ -2681,6 +2712,7 @@
               </a:defRPr>
             </a:lvl1pPr>
             <a:lvl2pPr>
+              <a:buNone/>
               <a:defRPr sz="2175" b="0">
                 <a:solidFill>
                   <a:srgbClr val="172B4D"/>
@@ -2691,6 +2723,7 @@
               </a:defRPr>
             </a:lvl2pPr>
             <a:lvl3pPr>
+              <a:buNone/>
               <a:defRPr sz="2175" b="0">
                 <a:solidFill>
                   <a:srgbClr val="172B4D"/>
@@ -2701,6 +2734,7 @@
               </a:defRPr>
             </a:lvl3pPr>
             <a:lvl4pPr>
+              <a:buNone/>
               <a:defRPr sz="2175" b="0">
                 <a:solidFill>
                   <a:srgbClr val="172B4D"/>
@@ -2711,6 +2745,7 @@
               </a:defRPr>
             </a:lvl4pPr>
             <a:lvl5pPr>
+              <a:buNone/>
               <a:defRPr sz="2175" b="0">
                 <a:solidFill>
                   <a:srgbClr val="172B4D"/>
@@ -2721,6 +2756,7 @@
               </a:defRPr>
             </a:lvl5pPr>
             <a:lvl6pPr>
+              <a:buNone/>
               <a:defRPr sz="2175" b="0">
                 <a:solidFill>
                   <a:srgbClr val="172B4D"/>
@@ -2731,6 +2767,7 @@
               </a:defRPr>
             </a:lvl6pPr>
             <a:lvl7pPr>
+              <a:buNone/>
               <a:defRPr sz="2175" b="0">
                 <a:solidFill>
                   <a:srgbClr val="172B4D"/>
@@ -2741,6 +2778,7 @@
               </a:defRPr>
             </a:lvl7pPr>
             <a:lvl8pPr>
+              <a:buNone/>
               <a:defRPr sz="2175" b="0">
                 <a:solidFill>
                   <a:srgbClr val="172B4D"/>
@@ -2751,6 +2789,7 @@
               </a:defRPr>
             </a:lvl8pPr>
             <a:lvl9pPr>
+              <a:buNone/>
               <a:defRPr sz="2175" b="0">
                 <a:solidFill>
                   <a:srgbClr val="172B4D"/>
@@ -2763,6 +2802,7 @@
           </a:lstStyle>
           <a:p xmlns:a="http://schemas.openxmlformats.org/drawingml/2006/main">
             <a:pPr>
+              <a:buNone/>
               <a:defRPr sz="2175" b="0">
                 <a:solidFill>
                   <a:srgbClr val="172B4D"/>
@@ -2829,6 +2869,7 @@
               </a:defRPr>
             </a:defPPr>
             <a:lvl1pPr>
+              <a:buNone/>
               <a:defRPr sz="1650" b="0">
                 <a:solidFill>
                   <a:srgbClr val="475569"/>
@@ -2839,6 +2880,7 @@
               </a:defRPr>
             </a:lvl1pPr>
             <a:lvl2pPr>
+              <a:buNone/>
               <a:defRPr sz="1650" b="0">
                 <a:solidFill>
                   <a:srgbClr val="475569"/>
@@ -2849,6 +2891,7 @@
               </a:defRPr>
             </a:lvl2pPr>
             <a:lvl3pPr>
+              <a:buNone/>
               <a:defRPr sz="1650" b="0">
                 <a:solidFill>
                   <a:srgbClr val="475569"/>
@@ -2859,6 +2902,7 @@
               </a:defRPr>
             </a:lvl3pPr>
             <a:lvl4pPr>
+              <a:buNone/>
               <a:defRPr sz="1650" b="0">
                 <a:solidFill>
                   <a:srgbClr val="475569"/>
@@ -2869,6 +2913,7 @@
               </a:defRPr>
             </a:lvl4pPr>
             <a:lvl5pPr>
+              <a:buNone/>
               <a:defRPr sz="1650" b="0">
                 <a:solidFill>
                   <a:srgbClr val="475569"/>
@@ -2879,6 +2924,7 @@
               </a:defRPr>
             </a:lvl5pPr>
             <a:lvl6pPr>
+              <a:buNone/>
               <a:defRPr sz="1650" b="0">
                 <a:solidFill>
                   <a:srgbClr val="475569"/>
@@ -2889,6 +2935,7 @@
               </a:defRPr>
             </a:lvl6pPr>
             <a:lvl7pPr>
+              <a:buNone/>
               <a:defRPr sz="1650" b="0">
                 <a:solidFill>
                   <a:srgbClr val="475569"/>
@@ -2899,6 +2946,7 @@
               </a:defRPr>
             </a:lvl7pPr>
             <a:lvl8pPr>
+              <a:buNone/>
               <a:defRPr sz="1650" b="0">
                 <a:solidFill>
                   <a:srgbClr val="475569"/>
@@ -2909,6 +2957,7 @@
               </a:defRPr>
             </a:lvl8pPr>
             <a:lvl9pPr>
+              <a:buNone/>
               <a:defRPr sz="1650" b="0">
                 <a:solidFill>
                   <a:srgbClr val="475569"/>
@@ -2921,6 +2970,7 @@
           </a:lstStyle>
           <a:p xmlns:a="http://schemas.openxmlformats.org/drawingml/2006/main">
             <a:pPr>
+              <a:buNone/>
               <a:defRPr sz="1650" b="0">
                 <a:solidFill>
                   <a:srgbClr val="475569"/>
@@ -3417,6 +3467,7 @@
               </a:defRPr>
             </a:defPPr>
             <a:lvl1pPr>
+              <a:buNone/>
               <a:defRPr sz="2175" b="0">
                 <a:solidFill>
                   <a:srgbClr val="172B4D"/>
@@ -3427,6 +3478,7 @@
               </a:defRPr>
             </a:lvl1pPr>
             <a:lvl2pPr>
+              <a:buNone/>
               <a:defRPr sz="2175" b="0">
                 <a:solidFill>
                   <a:srgbClr val="172B4D"/>
@@ -3437,6 +3489,7 @@
               </a:defRPr>
             </a:lvl2pPr>
             <a:lvl3pPr>
+              <a:buNone/>
               <a:defRPr sz="2175" b="0">
                 <a:solidFill>
                   <a:srgbClr val="172B4D"/>
@@ -3447,6 +3500,7 @@
               </a:defRPr>
             </a:lvl3pPr>
             <a:lvl4pPr>
+              <a:buNone/>
               <a:defRPr sz="2175" b="0">
                 <a:solidFill>
                   <a:srgbClr val="172B4D"/>
@@ -3457,6 +3511,7 @@
               </a:defRPr>
             </a:lvl4pPr>
             <a:lvl5pPr>
+              <a:buNone/>
               <a:defRPr sz="2175" b="0">
                 <a:solidFill>
                   <a:srgbClr val="172B4D"/>
@@ -3467,6 +3522,7 @@
               </a:defRPr>
             </a:lvl5pPr>
             <a:lvl6pPr>
+              <a:buNone/>
               <a:defRPr sz="2175" b="0">
                 <a:solidFill>
                   <a:srgbClr val="172B4D"/>
@@ -3477,6 +3533,7 @@
               </a:defRPr>
             </a:lvl6pPr>
             <a:lvl7pPr>
+              <a:buNone/>
               <a:defRPr sz="2175" b="0">
                 <a:solidFill>
                   <a:srgbClr val="172B4D"/>
@@ -3487,6 +3544,7 @@
               </a:defRPr>
             </a:lvl7pPr>
             <a:lvl8pPr>
+              <a:buNone/>
               <a:defRPr sz="2175" b="0">
                 <a:solidFill>
                   <a:srgbClr val="172B4D"/>
@@ -3497,6 +3555,7 @@
               </a:defRPr>
             </a:lvl8pPr>
             <a:lvl9pPr>
+              <a:buNone/>
               <a:defRPr sz="2175" b="0">
                 <a:solidFill>
                   <a:srgbClr val="172B4D"/>
@@ -3509,6 +3568,7 @@
           </a:lstStyle>
           <a:p xmlns:a="http://schemas.openxmlformats.org/drawingml/2006/main">
             <a:pPr>
+              <a:buNone/>
               <a:defRPr sz="2175" b="0">
                 <a:solidFill>
                   <a:srgbClr val="172B4D"/>
@@ -3575,6 +3635,7 @@
               </a:defRPr>
             </a:defPPr>
             <a:lvl1pPr>
+              <a:buNone/>
               <a:defRPr sz="2175" b="0">
                 <a:solidFill>
                   <a:srgbClr val="172B4D"/>
@@ -3585,6 +3646,7 @@
               </a:defRPr>
             </a:lvl1pPr>
             <a:lvl2pPr>
+              <a:buNone/>
               <a:defRPr sz="2175" b="0">
                 <a:solidFill>
                   <a:srgbClr val="172B4D"/>
@@ -3595,6 +3657,7 @@
               </a:defRPr>
             </a:lvl2pPr>
             <a:lvl3pPr>
+              <a:buNone/>
               <a:defRPr sz="2175" b="0">
                 <a:solidFill>
                   <a:srgbClr val="172B4D"/>
@@ -3605,6 +3668,7 @@
               </a:defRPr>
             </a:lvl3pPr>
             <a:lvl4pPr>
+              <a:buNone/>
               <a:defRPr sz="2175" b="0">
                 <a:solidFill>
                   <a:srgbClr val="172B4D"/>
@@ -3615,6 +3679,7 @@
               </a:defRPr>
             </a:lvl4pPr>
             <a:lvl5pPr>
+              <a:buNone/>
               <a:defRPr sz="2175" b="0">
                 <a:solidFill>
                   <a:srgbClr val="172B4D"/>
@@ -3625,6 +3690,7 @@
               </a:defRPr>
             </a:lvl5pPr>
             <a:lvl6pPr>
+              <a:buNone/>
               <a:defRPr sz="2175" b="0">
                 <a:solidFill>
                   <a:srgbClr val="172B4D"/>
@@ -3635,6 +3701,7 @@
               </a:defRPr>
             </a:lvl6pPr>
             <a:lvl7pPr>
+              <a:buNone/>
               <a:defRPr sz="2175" b="0">
                 <a:solidFill>
                   <a:srgbClr val="172B4D"/>
@@ -3645,6 +3712,7 @@
               </a:defRPr>
             </a:lvl7pPr>
             <a:lvl8pPr>
+              <a:buNone/>
               <a:defRPr sz="2175" b="0">
                 <a:solidFill>
                   <a:srgbClr val="172B4D"/>
@@ -3655,6 +3723,7 @@
               </a:defRPr>
             </a:lvl8pPr>
             <a:lvl9pPr>
+              <a:buNone/>
               <a:defRPr sz="2175" b="0">
                 <a:solidFill>
                   <a:srgbClr val="172B4D"/>
@@ -3667,6 +3736,7 @@
           </a:lstStyle>
           <a:p xmlns:a="http://schemas.openxmlformats.org/drawingml/2006/main">
             <a:pPr>
+              <a:buNone/>
               <a:defRPr sz="2175" b="0">
                 <a:solidFill>
                   <a:srgbClr val="172B4D"/>
@@ -3733,6 +3803,7 @@
               </a:defRPr>
             </a:defPPr>
             <a:lvl1pPr>
+              <a:buNone/>
               <a:defRPr sz="2175" b="0">
                 <a:solidFill>
                   <a:srgbClr val="172B4D"/>
@@ -3743,6 +3814,7 @@
               </a:defRPr>
             </a:lvl1pPr>
             <a:lvl2pPr>
+              <a:buNone/>
               <a:defRPr sz="2175" b="0">
                 <a:solidFill>
                   <a:srgbClr val="172B4D"/>
@@ -3753,6 +3825,7 @@
               </a:defRPr>
             </a:lvl2pPr>
             <a:lvl3pPr>
+              <a:buNone/>
               <a:defRPr sz="2175" b="0">
                 <a:solidFill>
                   <a:srgbClr val="172B4D"/>
@@ -3763,6 +3836,7 @@
               </a:defRPr>
             </a:lvl3pPr>
             <a:lvl4pPr>
+              <a:buNone/>
               <a:defRPr sz="2175" b="0">
                 <a:solidFill>
                   <a:srgbClr val="172B4D"/>
@@ -3773,6 +3847,7 @@
               </a:defRPr>
             </a:lvl4pPr>
             <a:lvl5pPr>
+              <a:buNone/>
               <a:defRPr sz="2175" b="0">
                 <a:solidFill>
                   <a:srgbClr val="172B4D"/>
@@ -3783,6 +3858,7 @@
               </a:defRPr>
             </a:lvl5pPr>
             <a:lvl6pPr>
+              <a:buNone/>
               <a:defRPr sz="2175" b="0">
                 <a:solidFill>
                   <a:srgbClr val="172B4D"/>
@@ -3793,6 +3869,7 @@
               </a:defRPr>
             </a:lvl6pPr>
             <a:lvl7pPr>
+              <a:buNone/>
               <a:defRPr sz="2175" b="0">
                 <a:solidFill>
                   <a:srgbClr val="172B4D"/>
@@ -3803,6 +3880,7 @@
               </a:defRPr>
             </a:lvl7pPr>
             <a:lvl8pPr>
+              <a:buNone/>
               <a:defRPr sz="2175" b="0">
                 <a:solidFill>
                   <a:srgbClr val="172B4D"/>
@@ -3813,6 +3891,7 @@
               </a:defRPr>
             </a:lvl8pPr>
             <a:lvl9pPr>
+              <a:buNone/>
               <a:defRPr sz="2175" b="0">
                 <a:solidFill>
                   <a:srgbClr val="172B4D"/>
@@ -3825,6 +3904,7 @@
           </a:lstStyle>
           <a:p xmlns:a="http://schemas.openxmlformats.org/drawingml/2006/main">
             <a:pPr>
+              <a:buNone/>
               <a:defRPr sz="2175" b="0">
                 <a:solidFill>
                   <a:srgbClr val="172B4D"/>
@@ -3891,6 +3971,7 @@
               </a:defRPr>
             </a:defPPr>
             <a:lvl1pPr>
+              <a:buNone/>
               <a:defRPr sz="2175" b="0">
                 <a:solidFill>
                   <a:srgbClr val="172B4D"/>
@@ -3901,6 +3982,7 @@
               </a:defRPr>
             </a:lvl1pPr>
             <a:lvl2pPr>
+              <a:buNone/>
               <a:defRPr sz="2175" b="0">
                 <a:solidFill>
                   <a:srgbClr val="172B4D"/>
@@ -3911,6 +3993,7 @@
               </a:defRPr>
             </a:lvl2pPr>
             <a:lvl3pPr>
+              <a:buNone/>
               <a:defRPr sz="2175" b="0">
                 <a:solidFill>
                   <a:srgbClr val="172B4D"/>
@@ -3921,6 +4004,7 @@
               </a:defRPr>
             </a:lvl3pPr>
             <a:lvl4pPr>
+              <a:buNone/>
               <a:defRPr sz="2175" b="0">
                 <a:solidFill>
                   <a:srgbClr val="172B4D"/>
@@ -3931,6 +4015,7 @@
               </a:defRPr>
             </a:lvl4pPr>
             <a:lvl5pPr>
+              <a:buNone/>
               <a:defRPr sz="2175" b="0">
                 <a:solidFill>
                   <a:srgbClr val="172B4D"/>
@@ -3941,6 +4026,7 @@
               </a:defRPr>
             </a:lvl5pPr>
             <a:lvl6pPr>
+              <a:buNone/>
               <a:defRPr sz="2175" b="0">
                 <a:solidFill>
                   <a:srgbClr val="172B4D"/>
@@ -3951,6 +4037,7 @@
               </a:defRPr>
             </a:lvl6pPr>
             <a:lvl7pPr>
+              <a:buNone/>
               <a:defRPr sz="2175" b="0">
                 <a:solidFill>
                   <a:srgbClr val="172B4D"/>
@@ -3961,6 +4048,7 @@
               </a:defRPr>
             </a:lvl7pPr>
             <a:lvl8pPr>
+              <a:buNone/>
               <a:defRPr sz="2175" b="0">
                 <a:solidFill>
                   <a:srgbClr val="172B4D"/>
@@ -3971,6 +4059,7 @@
               </a:defRPr>
             </a:lvl8pPr>
             <a:lvl9pPr>
+              <a:buNone/>
               <a:defRPr sz="2175" b="0">
                 <a:solidFill>
                   <a:srgbClr val="172B4D"/>
@@ -3983,6 +4072,7 @@
           </a:lstStyle>
           <a:p xmlns:a="http://schemas.openxmlformats.org/drawingml/2006/main">
             <a:pPr>
+              <a:buNone/>
               <a:defRPr sz="2175" b="0">
                 <a:solidFill>
                   <a:srgbClr val="172B4D"/>
@@ -4156,7 +4246,7 @@
           <p:cNvPr id="7" name="">
             <a:extLst xmlns:a="http://schemas.openxmlformats.org/drawingml/2006/main">
               <a:ext uri="{FF2B5EF4-FFF2-40B4-BE49-F238E27FC236}">
-                <a16:creationId xmlns:a16="http://schemas.microsoft.com/office/drawing/2014/main" id="{AC81670B-A2B1-4F46-84C2-4EE35947AC4B}"/>
+                <a16:creationId xmlns:a16="http://schemas.microsoft.com/office/drawing/2014/main" id="{09291405-1A40-4663-BEC0-D3CCF2A2EE5F}"/>
               </a:ext>
             </a:extLst>
           </p:cNvPr>
@@ -4851,6 +4941,7 @@
               </a:defRPr>
             </a:defPPr>
             <a:lvl1pPr>
+              <a:buNone/>
               <a:defRPr sz="1800" b="0">
                 <a:solidFill>
                   <a:srgbClr val="172B4D"/>
@@ -4861,6 +4952,7 @@
               </a:defRPr>
             </a:lvl1pPr>
             <a:lvl2pPr>
+              <a:buNone/>
               <a:defRPr sz="1800" b="0">
                 <a:solidFill>
                   <a:srgbClr val="172B4D"/>
@@ -4871,6 +4963,7 @@
               </a:defRPr>
             </a:lvl2pPr>
             <a:lvl3pPr>
+              <a:buNone/>
               <a:defRPr sz="1800" b="0">
                 <a:solidFill>
                   <a:srgbClr val="172B4D"/>
@@ -4881,6 +4974,7 @@
               </a:defRPr>
             </a:lvl3pPr>
             <a:lvl4pPr>
+              <a:buNone/>
               <a:defRPr sz="1800" b="0">
                 <a:solidFill>
                   <a:srgbClr val="172B4D"/>
@@ -4891,6 +4985,7 @@
               </a:defRPr>
             </a:lvl4pPr>
             <a:lvl5pPr>
+              <a:buNone/>
               <a:defRPr sz="1800" b="0">
                 <a:solidFill>
                   <a:srgbClr val="172B4D"/>
@@ -4901,6 +4996,7 @@
               </a:defRPr>
             </a:lvl5pPr>
             <a:lvl6pPr>
+              <a:buNone/>
               <a:defRPr sz="1800" b="0">
                 <a:solidFill>
                   <a:srgbClr val="172B4D"/>
@@ -4911,6 +5007,7 @@
               </a:defRPr>
             </a:lvl6pPr>
             <a:lvl7pPr>
+              <a:buNone/>
               <a:defRPr sz="1800" b="0">
                 <a:solidFill>
                   <a:srgbClr val="172B4D"/>
@@ -4921,6 +5018,7 @@
               </a:defRPr>
             </a:lvl7pPr>
             <a:lvl8pPr>
+              <a:buNone/>
               <a:defRPr sz="1800" b="0">
                 <a:solidFill>
                   <a:srgbClr val="172B4D"/>
@@ -4931,6 +5029,7 @@
               </a:defRPr>
             </a:lvl8pPr>
             <a:lvl9pPr>
+              <a:buNone/>
               <a:defRPr sz="1800" b="0">
                 <a:solidFill>
                   <a:srgbClr val="172B4D"/>
@@ -5117,7 +5216,7 @@
           <p:cNvPr id="7" name="">
             <a:extLst xmlns:a="http://schemas.openxmlformats.org/drawingml/2006/main">
               <a:ext uri="{FF2B5EF4-FFF2-40B4-BE49-F238E27FC236}">
-                <a16:creationId xmlns:a16="http://schemas.microsoft.com/office/drawing/2014/main" id="{CF1EDBEF-06D6-4D5C-8FA8-18CC89D21D25}"/>
+                <a16:creationId xmlns:a16="http://schemas.microsoft.com/office/drawing/2014/main" id="{8831B123-3897-4CE7-89E7-2B256DB23C03}"/>
               </a:ext>
             </a:extLst>
           </p:cNvPr>
@@ -5812,6 +5911,7 @@
               </a:defRPr>
             </a:defPPr>
             <a:lvl1pPr>
+              <a:buNone/>
               <a:defRPr sz="1725" b="0">
                 <a:solidFill>
                   <a:srgbClr val="172B4D"/>
@@ -5822,6 +5922,7 @@
               </a:defRPr>
             </a:lvl1pPr>
             <a:lvl2pPr>
+              <a:buNone/>
               <a:defRPr sz="1725" b="0">
                 <a:solidFill>
                   <a:srgbClr val="172B4D"/>
@@ -5832,6 +5933,7 @@
               </a:defRPr>
             </a:lvl2pPr>
             <a:lvl3pPr>
+              <a:buNone/>
               <a:defRPr sz="1725" b="0">
                 <a:solidFill>
                   <a:srgbClr val="172B4D"/>
@@ -5842,6 +5944,7 @@
               </a:defRPr>
             </a:lvl3pPr>
             <a:lvl4pPr>
+              <a:buNone/>
               <a:defRPr sz="1725" b="0">
                 <a:solidFill>
                   <a:srgbClr val="172B4D"/>
@@ -5852,6 +5955,7 @@
               </a:defRPr>
             </a:lvl4pPr>
             <a:lvl5pPr>
+              <a:buNone/>
               <a:defRPr sz="1725" b="0">
                 <a:solidFill>
                   <a:srgbClr val="172B4D"/>
@@ -5862,6 +5966,7 @@
               </a:defRPr>
             </a:lvl5pPr>
             <a:lvl6pPr>
+              <a:buNone/>
               <a:defRPr sz="1725" b="0">
                 <a:solidFill>
                   <a:srgbClr val="172B4D"/>
@@ -5872,6 +5977,7 @@
               </a:defRPr>
             </a:lvl6pPr>
             <a:lvl7pPr>
+              <a:buNone/>
               <a:defRPr sz="1725" b="0">
                 <a:solidFill>
                   <a:srgbClr val="172B4D"/>
@@ -5882,6 +5988,7 @@
               </a:defRPr>
             </a:lvl7pPr>
             <a:lvl8pPr>
+              <a:buNone/>
               <a:defRPr sz="1725" b="0">
                 <a:solidFill>
                   <a:srgbClr val="172B4D"/>
@@ -5892,6 +5999,7 @@
               </a:defRPr>
             </a:lvl8pPr>
             <a:lvl9pPr>
+              <a:buNone/>
               <a:defRPr sz="1725" b="0">
                 <a:solidFill>
                   <a:srgbClr val="172B4D"/>
@@ -6102,7 +6210,7 @@
           <p:cNvPr id="7" name="">
             <a:extLst xmlns:a="http://schemas.openxmlformats.org/drawingml/2006/main">
               <a:ext uri="{FF2B5EF4-FFF2-40B4-BE49-F238E27FC236}">
-                <a16:creationId xmlns:a16="http://schemas.microsoft.com/office/drawing/2014/main" id="{1D7006BE-152A-4B48-A22D-3E9805C60A5B}"/>
+                <a16:creationId xmlns:a16="http://schemas.microsoft.com/office/drawing/2014/main" id="{4B5DDBA9-F8EF-4114-BFC2-3042574A78D1}"/>
               </a:ext>
             </a:extLst>
           </p:cNvPr>
@@ -6919,6 +7027,7 @@
               </a:defRPr>
             </a:defPPr>
             <a:lvl1pPr>
+              <a:buNone/>
               <a:defRPr sz="1800" b="0">
                 <a:solidFill>
                   <a:srgbClr val="172B4D"/>
@@ -6929,6 +7038,7 @@
               </a:defRPr>
             </a:lvl1pPr>
             <a:lvl2pPr>
+              <a:buNone/>
               <a:defRPr sz="1800" b="0">
                 <a:solidFill>
                   <a:srgbClr val="172B4D"/>
@@ -6939,6 +7049,7 @@
               </a:defRPr>
             </a:lvl2pPr>
             <a:lvl3pPr>
+              <a:buNone/>
               <a:defRPr sz="1800" b="0">
                 <a:solidFill>
                   <a:srgbClr val="172B4D"/>
@@ -6949,6 +7060,7 @@
               </a:defRPr>
             </a:lvl3pPr>
             <a:lvl4pPr>
+              <a:buNone/>
               <a:defRPr sz="1800" b="0">
                 <a:solidFill>
                   <a:srgbClr val="172B4D"/>
@@ -6959,6 +7071,7 @@
               </a:defRPr>
             </a:lvl4pPr>
             <a:lvl5pPr>
+              <a:buNone/>
               <a:defRPr sz="1800" b="0">
                 <a:solidFill>
                   <a:srgbClr val="172B4D"/>
@@ -6969,6 +7082,7 @@
               </a:defRPr>
             </a:lvl5pPr>
             <a:lvl6pPr>
+              <a:buNone/>
               <a:defRPr sz="1800" b="0">
                 <a:solidFill>
                   <a:srgbClr val="172B4D"/>
@@ -6979,6 +7093,7 @@
               </a:defRPr>
             </a:lvl6pPr>
             <a:lvl7pPr>
+              <a:buNone/>
               <a:defRPr sz="1800" b="0">
                 <a:solidFill>
                   <a:srgbClr val="172B4D"/>
@@ -6989,6 +7104,7 @@
               </a:defRPr>
             </a:lvl7pPr>
             <a:lvl8pPr>
+              <a:buNone/>
               <a:defRPr sz="1800" b="0">
                 <a:solidFill>
                   <a:srgbClr val="172B4D"/>
@@ -6999,6 +7115,7 @@
               </a:defRPr>
             </a:lvl8pPr>
             <a:lvl9pPr>
+              <a:buNone/>
               <a:defRPr sz="1800" b="0">
                 <a:solidFill>
                   <a:srgbClr val="172B4D"/>
@@ -7030,7 +7147,7 @@
                 <a:ea typeface="Arial"/>
                 <a:cs typeface="Arial"/>
               </a:rPr>
-              <a:t>Um 503 síncrono deixou registro no banco, sem marco de commit.</a:t>
+              <a:t>Um evento síncrono apareceu no banco apesar de HTTP 503, sem horário de commit.</a:t>
             </a:r>
           </a:p>
           <a:p xmlns:a="http://schemas.openxmlformats.org/drawingml/2006/main">
@@ -7209,7 +7326,7 @@
           <p:cNvPr id="6" name="">
             <a:extLst xmlns:a="http://schemas.openxmlformats.org/drawingml/2006/main">
               <a:ext uri="{FF2B5EF4-FFF2-40B4-BE49-F238E27FC236}">
-                <a16:creationId xmlns:a16="http://schemas.microsoft.com/office/drawing/2014/main" id="{48189336-6D1C-49C6-AAEF-2D1199DB359B}"/>
+                <a16:creationId xmlns:a16="http://schemas.microsoft.com/office/drawing/2014/main" id="{545E4624-631C-40D1-96A2-8A373515B49D}"/>
               </a:ext>
             </a:extLst>
           </p:cNvPr>
@@ -7707,6 +7824,7 @@
               </a:defRPr>
             </a:defPPr>
             <a:lvl1pPr>
+              <a:buNone/>
               <a:defRPr sz="1800" b="0">
                 <a:solidFill>
                   <a:srgbClr val="172B4D"/>
@@ -7717,6 +7835,7 @@
               </a:defRPr>
             </a:lvl1pPr>
             <a:lvl2pPr>
+              <a:buNone/>
               <a:defRPr sz="1800" b="0">
                 <a:solidFill>
                   <a:srgbClr val="172B4D"/>
@@ -7727,6 +7846,7 @@
               </a:defRPr>
             </a:lvl2pPr>
             <a:lvl3pPr>
+              <a:buNone/>
               <a:defRPr sz="1800" b="0">
                 <a:solidFill>
                   <a:srgbClr val="172B4D"/>
@@ -7737,6 +7857,7 @@
               </a:defRPr>
             </a:lvl3pPr>
             <a:lvl4pPr>
+              <a:buNone/>
               <a:defRPr sz="1800" b="0">
                 <a:solidFill>
                   <a:srgbClr val="172B4D"/>
@@ -7747,6 +7868,7 @@
               </a:defRPr>
             </a:lvl4pPr>
             <a:lvl5pPr>
+              <a:buNone/>
               <a:defRPr sz="1800" b="0">
                 <a:solidFill>
                   <a:srgbClr val="172B4D"/>
@@ -7757,6 +7879,7 @@
               </a:defRPr>
             </a:lvl5pPr>
             <a:lvl6pPr>
+              <a:buNone/>
               <a:defRPr sz="1800" b="0">
                 <a:solidFill>
                   <a:srgbClr val="172B4D"/>
@@ -7767,6 +7890,7 @@
               </a:defRPr>
             </a:lvl6pPr>
             <a:lvl7pPr>
+              <a:buNone/>
               <a:defRPr sz="1800" b="0">
                 <a:solidFill>
                   <a:srgbClr val="172B4D"/>
@@ -7777,6 +7901,7 @@
               </a:defRPr>
             </a:lvl7pPr>
             <a:lvl8pPr>
+              <a:buNone/>
               <a:defRPr sz="1800" b="0">
                 <a:solidFill>
                   <a:srgbClr val="172B4D"/>
@@ -7787,6 +7912,7 @@
               </a:defRPr>
             </a:lvl8pPr>
             <a:lvl9pPr>
+              <a:buNone/>
               <a:defRPr sz="1800" b="0">
                 <a:solidFill>
                   <a:srgbClr val="172B4D"/>
@@ -7799,6 +7925,7 @@
           </a:lstStyle>
           <a:p xmlns:a="http://schemas.openxmlformats.org/drawingml/2006/main">
             <a:pPr>
+              <a:buNone/>
               <a:defRPr sz="1800" b="0">
                 <a:solidFill>
                   <a:srgbClr val="172B4D"/>
@@ -7822,6 +7949,7 @@
           </a:p>
           <a:p xmlns:a="http://schemas.openxmlformats.org/drawingml/2006/main">
             <a:pPr>
+              <a:buNone/>
               <a:defRPr sz="1800" b="0">
                 <a:solidFill>
                   <a:srgbClr val="172B4D"/>
@@ -7927,7 +8055,7 @@
                 <a:ea typeface="Arial"/>
                 <a:cs typeface="Arial"/>
               </a:rPr>
-              <a:t>A1: uma coleta parcial preservada</a:t>
+              <a:t>Por que uma coleta ficou parcial</a:t>
             </a:r>
           </a:p>
         </p:txBody>
@@ -7995,7 +8123,7 @@
           <p:cNvPr id="7" name="">
             <a:extLst xmlns:a="http://schemas.openxmlformats.org/drawingml/2006/main">
               <a:ext uri="{FF2B5EF4-FFF2-40B4-BE49-F238E27FC236}">
-                <a16:creationId xmlns:a16="http://schemas.microsoft.com/office/drawing/2014/main" id="{1669E9FD-91F7-491F-A06F-902E07EC9961}"/>
+                <a16:creationId xmlns:a16="http://schemas.microsoft.com/office/drawing/2014/main" id="{C769136D-92D9-495F-BA37-F4ACB32D6547}"/>
               </a:ext>
             </a:extLst>
           </p:cNvPr>
@@ -8032,7 +8160,7 @@
                           <a:ea typeface="Arial"/>
                           <a:cs typeface="Arial"/>
                         </a:rPr>
-                        <a:t>Aspecto</a:t>
+                        <a:t>O que aconteceu</a:t>
                       </a:r>
                     </a:p>
                   </a:txBody>
@@ -8082,7 +8210,7 @@
                           <a:ea typeface="Arial"/>
                           <a:cs typeface="Arial"/>
                         </a:rPr>
-                        <a:t>Tratamento</a:t>
+                        <a:t>Efeito na análise</a:t>
                       </a:r>
                     </a:p>
                   </a:txBody>
@@ -8172,7 +8300,7 @@
                           <a:ea typeface="Arial"/>
                           <a:cs typeface="Arial"/>
                         </a:rPr>
-                        <a:t>Veredito original</a:t>
+                        <a:t>Evento no banco apesar de HTTP 503</a:t>
                       </a:r>
                     </a:p>
                   </a:txBody>
@@ -8216,7 +8344,7 @@
                           <a:ea typeface="Arial"/>
                           <a:cs typeface="Arial"/>
                         </a:rPr>
-                        <a:t>Inválido, sem alteração</a:t>
+                        <a:t>Horário de um commit ausente</a:t>
                       </a:r>
                     </a:p>
                   </a:txBody>
@@ -8254,7 +8382,129 @@
                           <a:ea typeface="Arial"/>
                           <a:cs typeface="Arial"/>
                         </a:rPr>
-                        <a:t>1 coleta</a:t>
+                        <a:t>1 de 1.667 registros</a:t>
+                      </a:r>
+                    </a:p>
+                  </a:txBody>
+                  <a:tcPr marL="91440" marR="91440" marT="45720" marB="45720">
+                    <a:lnR w="9525">
+                      <a:solidFill>
+                        <a:srgbClr val="CBD5E1"/>
+                      </a:solidFill>
+                      <a:prstDash val="solid"/>
+                    </a:lnR>
+                    <a:lnB w="9525">
+                      <a:solidFill>
+                        <a:srgbClr val="CBD5E1"/>
+                      </a:solidFill>
+                      <a:prstDash val="solid"/>
+                    </a:lnB>
+                    <a:solidFill>
+                      <a:srgbClr val="FFFFFF"/>
+                    </a:solidFill>
+                  </a:tcPr>
+                </a:tc>
+              </a:tr>
+              <a:tr h="695325">
+                <a:tc>
+                  <a:txBody>
+                    <a:bodyPr>
+                      <a:noAutofit/>
+                    </a:bodyPr>
+                    <a:lstStyle/>
+                    <a:p>
+                      <a:r>
+                        <a:rPr sz="1800" b="0">
+                          <a:solidFill>
+                            <a:srgbClr val="172B4D"/>
+                          </a:solidFill>
+                          <a:latin typeface="Arial"/>
+                          <a:ea typeface="Arial"/>
+                          <a:cs typeface="Arial"/>
+                        </a:rPr>
+                        <a:t>Conclusão primária com banco parado</a:t>
+                      </a:r>
+                    </a:p>
+                  </a:txBody>
+                  <a:tcPr marL="91440" marR="91440" marT="45720" marB="45720">
+                    <a:lnL w="9525">
+                      <a:solidFill>
+                        <a:srgbClr val="CBD5E1"/>
+                      </a:solidFill>
+                      <a:prstDash val="solid"/>
+                    </a:lnL>
+                    <a:lnR w="9525">
+                      <a:solidFill>
+                        <a:srgbClr val="CBD5E1"/>
+                      </a:solidFill>
+                      <a:prstDash val="solid"/>
+                    </a:lnR>
+                    <a:lnB w="9525">
+                      <a:solidFill>
+                        <a:srgbClr val="CBD5E1"/>
+                      </a:solidFill>
+                      <a:prstDash val="solid"/>
+                    </a:lnB>
+                    <a:solidFill>
+                      <a:srgbClr val="FFFFFF"/>
+                    </a:solidFill>
+                  </a:tcPr>
+                </a:tc>
+                <a:tc>
+                  <a:txBody>
+                    <a:bodyPr>
+                      <a:noAutofit/>
+                    </a:bodyPr>
+                    <a:lstStyle/>
+                    <a:p>
+                      <a:r>
+                        <a:rPr sz="1800" b="0">
+                          <a:solidFill>
+                            <a:srgbClr val="172B4D"/>
+                          </a:solidFill>
+                          <a:latin typeface="Arial"/>
+                          <a:ea typeface="Arial"/>
+                          <a:cs typeface="Arial"/>
+                        </a:rPr>
+                        <a:t>Exclusão do par do bloco 3</a:t>
+                      </a:r>
+                    </a:p>
+                  </a:txBody>
+                  <a:tcPr marL="91440" marR="91440" marT="45720" marB="45720">
+                    <a:lnR w="9525">
+                      <a:solidFill>
+                        <a:srgbClr val="CBD5E1"/>
+                      </a:solidFill>
+                      <a:prstDash val="solid"/>
+                    </a:lnR>
+                    <a:lnB w="9525">
+                      <a:solidFill>
+                        <a:srgbClr val="CBD5E1"/>
+                      </a:solidFill>
+                      <a:prstDash val="solid"/>
+                    </a:lnB>
+                    <a:solidFill>
+                      <a:srgbClr val="FFFFFF"/>
+                    </a:solidFill>
+                  </a:tcPr>
+                </a:tc>
+                <a:tc>
+                  <a:txBody>
+                    <a:bodyPr>
+                      <a:noAutofit/>
+                    </a:bodyPr>
+                    <a:lstStyle/>
+                    <a:p>
+                      <a:r>
+                        <a:rPr sz="1800" b="0">
+                          <a:solidFill>
+                            <a:srgbClr val="172B4D"/>
+                          </a:solidFill>
+                          <a:latin typeface="Arial"/>
+                          <a:ea typeface="Arial"/>
+                          <a:cs typeface="Arial"/>
+                        </a:rPr>
+                        <a:t>4 pares completos</a:t>
                       </a:r>
                     </a:p>
                   </a:txBody>
@@ -8338,7 +8588,7 @@
                           <a:ea typeface="Arial"/>
                           <a:cs typeface="Arial"/>
                         </a:rPr>
-                        <a:t>Elegíveis após auditoria</a:t>
+                        <a:t>Observações auditadas mantidas</a:t>
                       </a:r>
                     </a:p>
                   </a:txBody>
@@ -8416,7 +8666,7 @@
                           <a:ea typeface="Arial"/>
                           <a:cs typeface="Arial"/>
                         </a:rPr>
-                        <a:t>Conclusão primária com banco parado</a:t>
+                        <a:t>Veredito original</a:t>
                       </a:r>
                     </a:p>
                   </a:txBody>
@@ -8460,7 +8710,7 @@
                           <a:ea typeface="Arial"/>
                           <a:cs typeface="Arial"/>
                         </a:rPr>
-                        <a:t>Exclusão do par do bloco 3</a:t>
+                        <a:t>Inválido, sem alteração</a:t>
                       </a:r>
                     </a:p>
                   </a:txBody>
@@ -8498,129 +8748,7 @@
                           <a:ea typeface="Arial"/>
                           <a:cs typeface="Arial"/>
                         </a:rPr>
-                        <a:t>4 pares</a:t>
-                      </a:r>
-                    </a:p>
-                  </a:txBody>
-                  <a:tcPr marL="91440" marR="91440" marT="45720" marB="45720">
-                    <a:lnR w="9525">
-                      <a:solidFill>
-                        <a:srgbClr val="CBD5E1"/>
-                      </a:solidFill>
-                      <a:prstDash val="solid"/>
-                    </a:lnR>
-                    <a:lnB w="9525">
-                      <a:solidFill>
-                        <a:srgbClr val="CBD5E1"/>
-                      </a:solidFill>
-                      <a:prstDash val="solid"/>
-                    </a:lnB>
-                    <a:solidFill>
-                      <a:srgbClr val="FFFFFF"/>
-                    </a:solidFill>
-                  </a:tcPr>
-                </a:tc>
-              </a:tr>
-              <a:tr h="695325">
-                <a:tc>
-                  <a:txBody>
-                    <a:bodyPr>
-                      <a:noAutofit/>
-                    </a:bodyPr>
-                    <a:lstStyle/>
-                    <a:p>
-                      <a:r>
-                        <a:rPr sz="1800" b="0">
-                          <a:solidFill>
-                            <a:srgbClr val="172B4D"/>
-                          </a:solidFill>
-                          <a:latin typeface="Arial"/>
-                          <a:ea typeface="Arial"/>
-                          <a:cs typeface="Arial"/>
-                        </a:rPr>
-                        <a:t>Horário do commit ausente</a:t>
-                      </a:r>
-                    </a:p>
-                  </a:txBody>
-                  <a:tcPr marL="91440" marR="91440" marT="45720" marB="45720">
-                    <a:lnL w="9525">
-                      <a:solidFill>
-                        <a:srgbClr val="CBD5E1"/>
-                      </a:solidFill>
-                      <a:prstDash val="solid"/>
-                    </a:lnL>
-                    <a:lnR w="9525">
-                      <a:solidFill>
-                        <a:srgbClr val="CBD5E1"/>
-                      </a:solidFill>
-                      <a:prstDash val="solid"/>
-                    </a:lnR>
-                    <a:lnB w="9525">
-                      <a:solidFill>
-                        <a:srgbClr val="CBD5E1"/>
-                      </a:solidFill>
-                      <a:prstDash val="solid"/>
-                    </a:lnB>
-                    <a:solidFill>
-                      <a:srgbClr val="FFFFFF"/>
-                    </a:solidFill>
-                  </a:tcPr>
-                </a:tc>
-                <a:tc>
-                  <a:txBody>
-                    <a:bodyPr>
-                      <a:noAutofit/>
-                    </a:bodyPr>
-                    <a:lstStyle/>
-                    <a:p>
-                      <a:r>
-                        <a:rPr sz="1800" b="0">
-                          <a:solidFill>
-                            <a:srgbClr val="172B4D"/>
-                          </a:solidFill>
-                          <a:latin typeface="Arial"/>
-                          <a:ea typeface="Arial"/>
-                          <a:cs typeface="Arial"/>
-                        </a:rPr>
-                        <a:t>Sem preenchimento</a:t>
-                      </a:r>
-                    </a:p>
-                  </a:txBody>
-                  <a:tcPr marL="91440" marR="91440" marT="45720" marB="45720">
-                    <a:lnR w="9525">
-                      <a:solidFill>
-                        <a:srgbClr val="CBD5E1"/>
-                      </a:solidFill>
-                      <a:prstDash val="solid"/>
-                    </a:lnR>
-                    <a:lnB w="9525">
-                      <a:solidFill>
-                        <a:srgbClr val="CBD5E1"/>
-                      </a:solidFill>
-                      <a:prstDash val="solid"/>
-                    </a:lnB>
-                    <a:solidFill>
-                      <a:srgbClr val="FFFFFF"/>
-                    </a:solidFill>
-                  </a:tcPr>
-                </a:tc>
-                <a:tc>
-                  <a:txBody>
-                    <a:bodyPr>
-                      <a:noAutofit/>
-                    </a:bodyPr>
-                    <a:lstStyle/>
-                    <a:p>
-                      <a:r>
-                        <a:rPr sz="1800" b="0">
-                          <a:solidFill>
-                            <a:srgbClr val="172B4D"/>
-                          </a:solidFill>
-                          <a:latin typeface="Arial"/>
-                          <a:ea typeface="Arial"/>
-                          <a:cs typeface="Arial"/>
-                        </a:rPr>
-                        <a:t>1 de 1.667 registros</a:t>
+                        <a:t>1 coleta</a:t>
                       </a:r>
                     </a:p>
                   </a:txBody>
@@ -8690,6 +8818,7 @@
               </a:defRPr>
             </a:defPPr>
             <a:lvl1pPr>
+              <a:buNone/>
               <a:defRPr sz="1800" b="0">
                 <a:solidFill>
                   <a:srgbClr val="172B4D"/>
@@ -8700,6 +8829,7 @@
               </a:defRPr>
             </a:lvl1pPr>
             <a:lvl2pPr>
+              <a:buNone/>
               <a:defRPr sz="1800" b="0">
                 <a:solidFill>
                   <a:srgbClr val="172B4D"/>
@@ -8710,6 +8840,7 @@
               </a:defRPr>
             </a:lvl2pPr>
             <a:lvl3pPr>
+              <a:buNone/>
               <a:defRPr sz="1800" b="0">
                 <a:solidFill>
                   <a:srgbClr val="172B4D"/>
@@ -8720,6 +8851,7 @@
               </a:defRPr>
             </a:lvl3pPr>
             <a:lvl4pPr>
+              <a:buNone/>
               <a:defRPr sz="1800" b="0">
                 <a:solidFill>
                   <a:srgbClr val="172B4D"/>
@@ -8730,6 +8862,7 @@
               </a:defRPr>
             </a:lvl4pPr>
             <a:lvl5pPr>
+              <a:buNone/>
               <a:defRPr sz="1800" b="0">
                 <a:solidFill>
                   <a:srgbClr val="172B4D"/>
@@ -8740,6 +8873,7 @@
               </a:defRPr>
             </a:lvl5pPr>
             <a:lvl6pPr>
+              <a:buNone/>
               <a:defRPr sz="1800" b="0">
                 <a:solidFill>
                   <a:srgbClr val="172B4D"/>
@@ -8750,6 +8884,7 @@
               </a:defRPr>
             </a:lvl6pPr>
             <a:lvl7pPr>
+              <a:buNone/>
               <a:defRPr sz="1800" b="0">
                 <a:solidFill>
                   <a:srgbClr val="172B4D"/>
@@ -8760,6 +8895,7 @@
               </a:defRPr>
             </a:lvl7pPr>
             <a:lvl8pPr>
+              <a:buNone/>
               <a:defRPr sz="1800" b="0">
                 <a:solidFill>
                   <a:srgbClr val="172B4D"/>
@@ -8770,6 +8906,7 @@
               </a:defRPr>
             </a:lvl8pPr>
             <a:lvl9pPr>
+              <a:buNone/>
               <a:defRPr sz="1800" b="0">
                 <a:solidFill>
                   <a:srgbClr val="172B4D"/>
@@ -8801,7 +8938,7 @@
                 <a:ea typeface="Arial"/>
                 <a:cs typeface="Arial"/>
               </a:rPr>
-              <a:t>A1: revisão após as primeiras 37 tentativas, antes das 28 restantes.</a:t>
+              <a:t>A parada do banco era planejada. A falta do horário de commit foi imprevista.</a:t>
             </a:r>
           </a:p>
           <a:p xmlns:a="http://schemas.openxmlformats.org/drawingml/2006/main">
@@ -8825,7 +8962,7 @@
                 <a:ea typeface="Arial"/>
                 <a:cs typeface="Arial"/>
               </a:rPr>
-              <a:t>Vazão da parcial limitada a [9,25556; 9,26111] eventos/s.</a:t>
+              <a:t>A1 após 37 tentativas, antes das 28 restantes. Sem estimar o horário ausente.</a:t>
             </a:r>
           </a:p>
         </p:txBody>
@@ -8980,7 +9117,7 @@
           <p:cNvPr id="8" name="">
             <a:extLst xmlns:a="http://schemas.openxmlformats.org/drawingml/2006/main">
               <a:ext uri="{FF2B5EF4-FFF2-40B4-BE49-F238E27FC236}">
-                <a16:creationId xmlns:a16="http://schemas.microsoft.com/office/drawing/2014/main" id="{A984A765-9267-467D-BA96-26BE7D8F7D76}"/>
+                <a16:creationId xmlns:a16="http://schemas.microsoft.com/office/drawing/2014/main" id="{4D61F798-F136-44DE-8396-35CB43A68296}"/>
               </a:ext>
             </a:extLst>
           </p:cNvPr>
@@ -9553,6 +9690,7 @@
               </a:defRPr>
             </a:defPPr>
             <a:lvl1pPr>
+              <a:buNone/>
               <a:defRPr sz="1725" b="0">
                 <a:solidFill>
                   <a:srgbClr val="172B4D"/>
@@ -9563,6 +9701,7 @@
               </a:defRPr>
             </a:lvl1pPr>
             <a:lvl2pPr>
+              <a:buNone/>
               <a:defRPr sz="1725" b="0">
                 <a:solidFill>
                   <a:srgbClr val="172B4D"/>
@@ -9573,6 +9712,7 @@
               </a:defRPr>
             </a:lvl2pPr>
             <a:lvl3pPr>
+              <a:buNone/>
               <a:defRPr sz="1725" b="0">
                 <a:solidFill>
                   <a:srgbClr val="172B4D"/>
@@ -9583,6 +9723,7 @@
               </a:defRPr>
             </a:lvl3pPr>
             <a:lvl4pPr>
+              <a:buNone/>
               <a:defRPr sz="1725" b="0">
                 <a:solidFill>
                   <a:srgbClr val="172B4D"/>
@@ -9593,6 +9734,7 @@
               </a:defRPr>
             </a:lvl4pPr>
             <a:lvl5pPr>
+              <a:buNone/>
               <a:defRPr sz="1725" b="0">
                 <a:solidFill>
                   <a:srgbClr val="172B4D"/>
@@ -9603,6 +9745,7 @@
               </a:defRPr>
             </a:lvl5pPr>
             <a:lvl6pPr>
+              <a:buNone/>
               <a:defRPr sz="1725" b="0">
                 <a:solidFill>
                   <a:srgbClr val="172B4D"/>
@@ -9613,6 +9756,7 @@
               </a:defRPr>
             </a:lvl6pPr>
             <a:lvl7pPr>
+              <a:buNone/>
               <a:defRPr sz="1725" b="0">
                 <a:solidFill>
                   <a:srgbClr val="172B4D"/>
@@ -9623,6 +9767,7 @@
               </a:defRPr>
             </a:lvl7pPr>
             <a:lvl8pPr>
+              <a:buNone/>
               <a:defRPr sz="1725" b="0">
                 <a:solidFill>
                   <a:srgbClr val="172B4D"/>
@@ -9633,6 +9778,7 @@
               </a:defRPr>
             </a:lvl8pPr>
             <a:lvl9pPr>
+              <a:buNone/>
               <a:defRPr sz="1725" b="0">
                 <a:solidFill>
                   <a:srgbClr val="172B4D"/>
@@ -9645,6 +9791,7 @@
           </a:lstStyle>
           <a:p xmlns:a="http://schemas.openxmlformats.org/drawingml/2006/main">
             <a:pPr>
+              <a:buNone/>
               <a:defRPr sz="1725" b="0">
                 <a:solidFill>
                   <a:srgbClr val="172B4D"/>
@@ -9668,6 +9815,7 @@
           </a:p>
           <a:p xmlns:a="http://schemas.openxmlformats.org/drawingml/2006/main">
             <a:pPr>
+              <a:buNone/>
               <a:defRPr sz="1725" b="0">
                 <a:solidFill>
                   <a:srgbClr val="172B4D"/>
@@ -9691,6 +9839,7 @@
           </a:p>
           <a:p xmlns:a="http://schemas.openxmlformats.org/drawingml/2006/main">
             <a:pPr>
+              <a:buNone/>
               <a:defRPr sz="1725" b="0">
                 <a:solidFill>
                   <a:srgbClr val="172B4D"/>

</xml_diff>